<commit_message>
docs: finalize minimal 2-column pipeline graphic, fix downward arrow, and update slides
</commit_message>
<xml_diff>
--- a/docs/slides_2slides.pptx
+++ b/docs/slides_2slides.pptx
@@ -3819,8 +3819,8 @@
         </p:blipFill>
         <p:spPr bwMode="auto">
           <a:xfrm>
-            <a:off x="457200" y="1790700"/>
-            <a:ext cx="8229600" cy="2184400"/>
+            <a:off x="457200" y="1778000"/>
+            <a:ext cx="8229600" cy="2235200"/>
           </a:xfrm>
           <a:prstGeom prst="rect">
             <a:avLst/>

</xml_diff>

<commit_message>
docs: simplify 2-slide deck, enlarge pipeline cards, and update previews
</commit_message>
<xml_diff>
--- a/docs/slides_2slides.pptx
+++ b/docs/slides_2slides.pptx
@@ -5,13 +5,12 @@
     <p:sldMasterId id="2147483648" r:id="rId1"/>
   </p:sldMasterIdLst>
   <p:notesMasterIdLst>
-    <p:notesMasterId r:id="rId6"/>
+    <p:notesMasterId r:id="rId5"/>
   </p:notesMasterIdLst>
   <p:sldIdLst>
     <p:sldId id="256" r:id="rId2"/>
     <p:sldId id="257" r:id="rId3"/>
     <p:sldId id="258" r:id="rId4"/>
-    <p:sldId id="259" r:id="rId5"/>
   </p:sldIdLst>
   <p:sldSz cx="9144000" cy="5143500" type="screen16x9"/>
   <p:notesSz cx="6858000" cy="9144000"/>
@@ -527,21 +526,7 @@
             </a:pPr>
             <a:r>
               <a:rPr/>
-              <a:t>When our chatbot generates an answer from European environmental documents, RAG Facts Check audits every single sentence in real time.</a:t>
-            </a:r>
-          </a:p>
-          <a:p>
-            <a:pPr lvl="0" indent="0" marL="0">
-              <a:buNone/>
-            </a:pPr>
-          </a:p>
-          <a:p>
-            <a:pPr lvl="0" indent="0" marL="0">
-              <a:buNone/>
-            </a:pPr>
-            <a:r>
-              <a:rPr/>
-              <a:t>Instead of treating the answer as one opaque block, our pipeline: 1. Decomposes the answer into atomic claims. If there’s an 8-row comparison table, it preserves row integrity and duplicates the header row across chunks so no column context is lost. 2. Batches claims together and places static source documents at the beginning of the prompt. Modern engines like vLLM and llama.cpp reuse the pre-computed KV-cache prefix, dropping verification latency down to 5 to 12 seconds. 3. Maps model evidence quotes back to exact character offsets in the original documents using a 4-stage locator that tolerates OCR artifacts, linebreaks, and smart quotes.</a:t>
+              <a:t>When the chatbot generates an answer from European environmental documents, RAG Facts Check audits every claim in real time: 1. Ingests the LLM answer alongside matched source documents. 2. Decomposes the answer into atomic claims. 3. Crossmatches each claim against referenced documents using an LLM judge. 4. Produces grounded verification verdicts, direct evidence citations, and hallucination flags.</a:t>
             </a:r>
           </a:p>
         </p:txBody>
@@ -563,7 +548,7 @@
           <a:p>
             <a:fld id="{18BDFEC3-8487-43E8-A154-7C12CBC1FFF2}" type="slidenum">
               <a:rPr lang="en-US"/>
-              <a:t>3</a:t>
+              <a:t>2</a:t>
             </a:fld>
             <a:endParaRPr lang="en-US"/>
           </a:p>
@@ -623,49 +608,7 @@
             </a:pPr>
             <a:r>
               <a:rPr/>
-              <a:t>For the user, this turns a black-box AI response into an auditable, transparent document.</a:t>
-            </a:r>
-          </a:p>
-          <a:p>
-            <a:pPr lvl="0" indent="0" marL="0">
-              <a:buNone/>
-            </a:pPr>
-          </a:p>
-          <a:p>
-            <a:pPr lvl="0" indent="0" marL="0">
-              <a:buNone/>
-            </a:pPr>
-            <a:r>
-              <a:rPr/>
-              <a:t>At the top, users see a calibrated 0-to-10 quality badge, like ‘8.5 / 10 Good’.</a:t>
-            </a:r>
-          </a:p>
-          <a:p>
-            <a:pPr lvl="0" indent="0" marL="0">
-              <a:buNone/>
-            </a:pPr>
-          </a:p>
-          <a:p>
-            <a:pPr lvl="0" indent="0" marL="0">
-              <a:buNone/>
-            </a:pPr>
-            <a:r>
-              <a:rPr/>
-              <a:t>Every sentence in the text is color-coded. Fully supported claims are highlighted in green, and clicking or hovering on them immediately reveals the exact quoted passage from official European legislation. If a claim relies on ungrounded model knowledge or lacks source evidence, it is flagged in yellow; and if the model contradicts the source, it is flagged in red.</a:t>
-            </a:r>
-          </a:p>
-          <a:p>
-            <a:pPr lvl="0" indent="0" marL="0">
-              <a:buNone/>
-            </a:pPr>
-          </a:p>
-          <a:p>
-            <a:pPr lvl="0" indent="0" marL="0">
-              <a:buNone/>
-            </a:pPr>
-            <a:r>
-              <a:rPr/>
-              <a:t>Because our backend directly satisfies the Halloumi endpoint contract, this integration is live today with zero modifications to the Volto frontend code.</a:t>
+              <a:t>The fact-checking engine provides automated verification for enterprise RAG: - Extracts atomic factual claims from generated chatbot answers. - Checks each claim against referenced source documents using an LLM judge. - Locates verbatim evidence spans and character offsets in the source text. - Accurately detects hallucinations by flagging statements that lack document grounding (Not Enough Info). - Produces a calibrated quality score reflecting overall answer trustworthiness.</a:t>
             </a:r>
           </a:p>
         </p:txBody>
@@ -687,7 +630,7 @@
           <a:p>
             <a:fld id="{18BDFEC3-8487-43E8-A154-7C12CBC1FFF2}" type="slidenum">
               <a:rPr lang="en-US"/>
-              <a:t>4</a:t>
+              <a:t>3</a:t>
             </a:fld>
             <a:endParaRPr lang="en-US"/>
           </a:p>
@@ -3726,7 +3669,7 @@
             <a:br/>
             <a:r>
               <a:rPr/>
-              <a:t>European Environment Agency (EEA) / Plone Chatbot</a:t>
+              <a:t>European Environment Agency (EEA)</a:t>
             </a:r>
           </a:p>
         </p:txBody>
@@ -3798,7 +3741,7 @@
             </a:pPr>
             <a:r>
               <a:rPr/>
-              <a:t>1. How It Works: Verification Pipeline</a:t>
+              <a:t>Verification Pipeline</a:t>
             </a:r>
           </a:p>
         </p:txBody>
@@ -3812,15 +3755,15 @@
           <p:nvPr/>
         </p:nvPicPr>
         <p:blipFill>
-          <a:blip r:embed="rId2"/>
+          <a:blip r:embed="rId3"/>
           <a:stretch>
             <a:fillRect/>
           </a:stretch>
         </p:blipFill>
         <p:spPr bwMode="auto">
           <a:xfrm>
-            <a:off x="457200" y="1778000"/>
-            <a:ext cx="8229600" cy="2235200"/>
+            <a:off x="457200" y="1600200"/>
+            <a:ext cx="8229600" cy="2565400"/>
           </a:xfrm>
           <a:prstGeom prst="rect">
             <a:avLst/>
@@ -3857,6 +3800,31 @@
       </p:grpSpPr>
       <p:sp>
         <p:nvSpPr>
+          <p:cNvPr id="2" name="Title 1"/>
+          <p:cNvSpPr>
+            <a:spLocks noGrp="1"/>
+          </p:cNvSpPr>
+          <p:nvPr>
+            <p:ph type="title"/>
+          </p:nvPr>
+        </p:nvSpPr>
+        <p:spPr/>
+        <p:txBody>
+          <a:bodyPr/>
+          <a:lstStyle/>
+          <a:p>
+            <a:pPr lvl="0" indent="0" marL="0">
+              <a:buNone/>
+            </a:pPr>
+            <a:r>
+              <a:rPr/>
+              <a:t>Claim-Level Verification &amp; Evidence</a:t>
+            </a:r>
+          </a:p>
+        </p:txBody>
+      </p:sp>
+      <p:sp>
+        <p:nvSpPr>
           <p:cNvPr id="3" name="Content Placeholder 2"/>
           <p:cNvSpPr>
             <a:spLocks noGrp="1"/>
@@ -3878,440 +3846,111 @@
             </a:pPr>
             <a:r>
               <a:rPr b="1"/>
-              <a:t>1. Table-Aware Chunking</a:t>
+              <a:t>Verification &amp; Grounding</a:t>
             </a:r>
           </a:p>
           <a:p>
             <a:pPr lvl="0"/>
             <a:r>
-              <a:rPr/>
-              <a:t>Splits long responses &amp; tables row-by-row.</a:t>
+              <a:rPr b="1"/>
+              <a:t>Claim Extraction:</a:t>
+            </a:r>
+            <a:r>
+              <a:t xml:space="preserve"> </a:t>
+            </a:r>
+            <a:r>
+              <a:rPr sz="1300"/>
+              <a:t xml:space="preserve"> Decomposes answer into atomic claims</a:t>
             </a:r>
           </a:p>
           <a:p>
             <a:pPr lvl="0"/>
             <a:r>
               <a:rPr b="1"/>
-              <a:t>Replicates table headers</a:t>
-            </a:r>
-            <a:r>
-              <a:rPr/>
-              <a:t> into every chunk so column context is never lost.</a:t>
-            </a:r>
-          </a:p>
-        </p:txBody>
-      </p:sp>
-      <p:sp>
-        <p:nvSpPr>
-          <p:cNvPr id="4" name="Content Placeholder 3"/>
-          <p:cNvSpPr>
-            <a:spLocks noGrp="1"/>
-          </p:cNvSpPr>
-          <p:nvPr>
-            <p:ph idx="2" sz="half"/>
-          </p:nvPr>
-        </p:nvSpPr>
-        <p:spPr/>
-        <p:txBody>
-          <a:bodyPr/>
-          <a:lstStyle/>
-          <a:p>
-            <a:pPr lvl="0" indent="0" marL="0">
-              <a:spcBef>
-                <a:spcPts val="3000"/>
-              </a:spcBef>
-              <a:buNone/>
-            </a:pPr>
+              <a:t>Source Grounding:</a:t>
+            </a:r>
+            <a:r>
+              <a:t xml:space="preserve"> </a:t>
+            </a:r>
+            <a:r>
+              <a:rPr sz="1300"/>
+              <a:t xml:space="preserve"> Verifies claims against source documents</a:t>
+            </a:r>
+          </a:p>
+          <a:p>
+            <a:pPr lvl="0"/>
             <a:r>
               <a:rPr b="1"/>
-              <a:t>2. KV-Cache Batching</a:t>
+              <a:t>Verbatim Evidence:</a:t>
+            </a:r>
+            <a:r>
+              <a:t xml:space="preserve"> </a:t>
+            </a:r>
+            <a:r>
+              <a:rPr sz="1300"/>
+              <a:t xml:space="preserve"> Locates exact quote &amp; offsets in sources</a:t>
             </a:r>
           </a:p>
           <a:p>
             <a:pPr lvl="0"/>
             <a:r>
-              <a:rPr/>
-              <a:t>Verifies up to 20 claims simultaneously.</a:t>
+              <a:rPr b="1"/>
+              <a:t>Hallucination Detection:</a:t>
+            </a:r>
+            <a:r>
+              <a:t xml:space="preserve"> </a:t>
+            </a:r>
+            <a:r>
+              <a:rPr sz="1300"/>
+              <a:t xml:space="preserve"> Flags ungrounded claims</a:t>
             </a:r>
           </a:p>
           <a:p>
             <a:pPr lvl="0"/>
             <a:r>
               <a:rPr b="1"/>
-              <a:t>Static document prefix</a:t>
-            </a:r>
-            <a:r>
-              <a:rPr/>
-              <a:t> reuses KV-cache in </a:t>
-            </a:r>
-            <a:r>
-              <a:rPr>
-                <a:latin typeface="Courier"/>
-              </a:rPr>
-              <a:t>vLLM</a:t>
-            </a:r>
-            <a:r>
-              <a:rPr/>
-              <a:t> / </a:t>
-            </a:r>
-            <a:r>
-              <a:rPr>
-                <a:latin typeface="Courier"/>
-              </a:rPr>
-              <a:t>llama.cpp</a:t>
-            </a:r>
-            <a:r>
-              <a:rPr/>
-              <a:t> (&gt;70% faster).</a:t>
-            </a:r>
-          </a:p>
-        </p:txBody>
-      </p:sp>
-    </p:spTree>
-  </p:cSld>
-</p:sld>
-</file>
-
-<file path=ppt/slides/slide4.xml><?xml version="1.0" encoding="utf-8"?>
-<p:sld xmlns:a="http://schemas.openxmlformats.org/drawingml/2006/main" xmlns:r="http://schemas.openxmlformats.org/officeDocument/2006/relationships" xmlns:p="http://schemas.openxmlformats.org/presentationml/2006/main">
-  <p:cSld>
-    <p:spTree>
-      <p:nvGrpSpPr>
-        <p:cNvPr id="1" name=""/>
-        <p:cNvGrpSpPr/>
-        <p:nvPr/>
-      </p:nvGrpSpPr>
-      <p:grpSpPr>
-        <a:xfrm>
-          <a:off x="0" y="0"/>
-          <a:ext cx="0" cy="0"/>
-          <a:chOff x="0" y="0"/>
-          <a:chExt cx="0" cy="0"/>
-        </a:xfrm>
-      </p:grpSpPr>
-      <p:sp>
-        <p:nvSpPr>
-          <p:cNvPr id="2" name="Title 1"/>
-          <p:cNvSpPr>
-            <a:spLocks noGrp="1"/>
-          </p:cNvSpPr>
-          <p:nvPr>
-            <p:ph type="title"/>
-          </p:nvPr>
-        </p:nvSpPr>
-        <p:spPr/>
-        <p:txBody>
-          <a:bodyPr/>
-          <a:lstStyle/>
-          <a:p>
-            <a:pPr lvl="0" indent="0" marL="0">
-              <a:buNone/>
-            </a:pPr>
-            <a:r>
-              <a:rPr/>
-              <a:t>2. User Experience: Calibrated Scoring &amp; Inline Verification</a:t>
-            </a:r>
-          </a:p>
-        </p:txBody>
-      </p:sp>
-      <mc:AlternateContent xmlns:mc="http://schemas.openxmlformats.org/markup-compatibility/2006">
-        <mc:Choice xmlns:a14="http://schemas.microsoft.com/office/drawing/2010/main" Requires="a14">
-          <p:sp>
-            <p:nvSpPr>
-              <p:cNvPr id="3" name="Content Placeholder 2"/>
-              <p:cNvSpPr>
-                <a:spLocks noGrp="1"/>
-              </p:cNvSpPr>
-              <p:nvPr>
-                <p:ph idx="1" sz="half"/>
-              </p:nvPr>
-            </p:nvSpPr>
-            <p:spPr/>
-            <p:txBody>
-              <a:bodyPr/>
-              <a:lstStyle/>
-              <a:p>
-                <a:pPr lvl="0" indent="0" marL="0">
-                  <a:spcBef>
-                    <a:spcPts val="3000"/>
-                  </a:spcBef>
-                  <a:buNone/>
-                </a:pPr>
-                <a:r>
-                  <a:rPr b="1"/>
-                  <a:t>Calibrated 0–10 Trust Score</a:t>
-                </a:r>
-              </a:p>
-              <a:p>
-                <a:pPr lvl="0" indent="0" marL="0">
-                  <a:buNone/>
-                </a:pPr>
-                <a14:m>
-                  <m:oMathPara xmlns:m="http://schemas.openxmlformats.org/officeDocument/2006/math">
-                    <m:oMathParaPr>
-                      <m:jc m:val="center"/>
-                    </m:oMathParaPr>
-                    <m:oMath>
-                      <m:r>
-                        <m:rPr>
-                          <m:nor/>
-                          <m:sty m:val="p"/>
-                        </m:rPr>
-                        <m:t>Score</m:t>
-                      </m:r>
-                      <m:r>
-                        <m:rPr>
-                          <m:sty m:val="p"/>
-                        </m:rPr>
-                        <m:t>=</m:t>
-                      </m:r>
-                      <m:r>
-                        <m:rPr>
-                          <m:nor/>
-                          <m:sty m:val="p"/>
-                        </m:rPr>
-                        <m:t>clamp</m:t>
-                      </m:r>
-                      <m:r>
-                        <m:rPr>
-                          <m:sty m:val="p"/>
-                        </m:rPr>
-                        <m:t>(</m:t>
-                      </m:r>
-                      <m:r>
-                        <m:rPr>
-                          <m:nor/>
-                          <m:sty m:val="p"/>
-                        </m:rPr>
-                        <m:t>Base</m:t>
-                      </m:r>
-                      <m:r>
-                        <m:rPr>
-                          <m:sty m:val="p"/>
-                        </m:rPr>
-                        <m:t>×</m:t>
-                      </m:r>
-                      <m:sSub>
-                        <m:e>
-                          <m:r>
-                            <m:t>P</m:t>
-                          </m:r>
-                        </m:e>
-                        <m:sub>
-                          <m:r>
-                            <m:rPr>
-                              <m:nor/>
-                              <m:sty m:val="p"/>
-                            </m:rPr>
-                            <m:t>cite</m:t>
-                          </m:r>
-                        </m:sub>
-                      </m:sSub>
-                      <m:r>
-                        <m:rPr>
-                          <m:sty m:val="p"/>
-                        </m:rPr>
-                        <m:t>×</m:t>
-                      </m:r>
-                      <m:sSub>
-                        <m:e>
-                          <m:r>
-                            <m:t>P</m:t>
-                          </m:r>
-                        </m:e>
-                        <m:sub>
-                          <m:r>
-                            <m:rPr>
-                              <m:nor/>
-                              <m:sty m:val="p"/>
-                            </m:rPr>
-                            <m:t>contra</m:t>
-                          </m:r>
-                        </m:sub>
-                      </m:sSub>
-                      <m:r>
-                        <m:rPr>
-                          <m:sty m:val="p"/>
-                        </m:rPr>
-                        <m:t>,</m:t>
-                      </m:r>
-                      <m:r>
-                        <m:t> </m:t>
-                      </m:r>
-                      <m:r>
-                        <m:t>0</m:t>
-                      </m:r>
-                      <m:r>
-                        <m:rPr>
-                          <m:sty m:val="p"/>
-                        </m:rPr>
-                        <m:t>,</m:t>
-                      </m:r>
-                      <m:r>
-                        <m:t> </m:t>
-                      </m:r>
-                      <m:r>
-                        <m:t>10</m:t>
-                      </m:r>
-                      <m:r>
-                        <m:rPr>
-                          <m:sty m:val="p"/>
-                        </m:rPr>
-                        <m:t>)</m:t>
-                      </m:r>
-                    </m:oMath>
-                  </m:oMathPara>
-                </a14:m>
-              </a:p>
-              <a:p>
-                <a:pPr lvl="0"/>
-                <a:r>
-                  <a:rPr b="1"/>
-                  <a:t>Deterministic Formula:</a:t>
-                </a:r>
-                <a:r>
-                  <a:rPr/>
-                  <a:t> Computed instantly without extra LLM overhead.</a:t>
-                </a:r>
-              </a:p>
-              <a:p>
-                <a:pPr lvl="0"/>
-                <a:r>
-                  <a:rPr b="1"/>
-                  <a:t>Tiered Confidence:</a:t>
-                </a:r>
-              </a:p>
-              <a:p>
-                <a:pPr lvl="1"/>
-                <a:r>
-                  <a:rPr/>
-                  <a:t>🟢 </a:t>
-                </a:r>
-                <a:r>
-                  <a:rPr b="1"/>
-                  <a:t>Green (Supported):</a:t>
-                </a:r>
-                <a:r>
-                  <a:rPr/>
-                  <a:t> Full credit; hoverable tooltip displays source quote.</a:t>
-                </a:r>
-              </a:p>
-              <a:p>
-                <a:pPr lvl="1"/>
-                <a:r>
-                  <a:rPr/>
-                  <a:t>🟡 </a:t>
-                </a:r>
-                <a:r>
-                  <a:rPr b="1"/>
-                  <a:t>Yellow (Low Confidence):</a:t>
-                </a:r>
-                <a:r>
-                  <a:rPr/>
-                  <a:t> Unverified claim; warns the user.</a:t>
-                </a:r>
-              </a:p>
-              <a:p>
-                <a:pPr lvl="1"/>
-                <a:r>
-                  <a:rPr/>
-                  <a:t>🔴 </a:t>
-                </a:r>
-                <a:r>
-                  <a:rPr b="1"/>
-                  <a:t>Red (Contradicted):</a:t>
-                </a:r>
-                <a:r>
-                  <a:rPr/>
-                  <a:t> Harsh penalty; alerts user to factual error.</a:t>
-                </a:r>
-              </a:p>
-              <a:p>
-                <a:pPr lvl="0"/>
-                <a:r>
-                  <a:rPr b="1"/>
-                  <a:t>Drop-in Middleware:</a:t>
-                </a:r>
-              </a:p>
-              <a:p>
-                <a:pPr lvl="1"/>
-                <a:r>
-                  <a:rPr/>
-                  <a:t>Native </a:t>
-                </a:r>
-                <a:r>
-                  <a:rPr>
-                    <a:latin typeface="Courier"/>
-                  </a:rPr>
-                  <a:t>/halloumi/generate</a:t>
-                </a:r>
-                <a:r>
-                  <a:rPr/>
-                  <a:t> endpoint requires zero frontend code changes in Volto.</a:t>
-                </a:r>
-              </a:p>
-            </p:txBody>
-          </p:sp>
-        </mc:Choice>
-      </mc:AlternateContent>
-      <p:sp>
-        <p:nvSpPr>
-          <p:cNvPr id="4" name="Content Placeholder 3"/>
-          <p:cNvSpPr>
-            <a:spLocks noGrp="1"/>
-          </p:cNvSpPr>
-          <p:nvPr>
-            <p:ph idx="2" sz="half"/>
-          </p:nvPr>
-        </p:nvSpPr>
-        <p:spPr/>
-        <p:txBody>
-          <a:bodyPr/>
-          <a:lstStyle/>
-          <a:p>
-            <a:pPr lvl="0" indent="0" marL="0">
-              <a:spcBef>
-                <a:spcPts val="3000"/>
-              </a:spcBef>
-              <a:buNone/>
-            </a:pPr>
-            <a:r>
-              <a:rPr b="1"/>
-              <a:t>[ Insert UI Screenshot Here ]</a:t>
-            </a:r>
-          </a:p>
-          <a:p>
-            <a:pPr lvl="0" indent="0">
-              <a:buNone/>
-            </a:pPr>
-            <a:r>
-              <a:rPr>
-                <a:latin typeface="Courier"/>
-              </a:rPr>
-              <a:t>+-------------------------------------------------------------+
-|  Volto Chatbot UI (volto-eea-chatbot)                       |
-|                                                             |
-|  [ Score Pill: 8.5 / 10 (Good) ]                            |
-|                                                             |
-|  The European Climate Law sets a binding net-zero           |
-|  target by 2050. [1]  &lt;-- [🟢 Supported | Hover: Quote]     |
-|                                                             |
-|  Member states must submit reports by Dec 2024. [2]         |
-|  &lt;-- [🟡 Low Confidence / Not Enough Info]                  |
-+-------------------------------------------------------------+</a:t>
-            </a:r>
-          </a:p>
-          <a:p>
-            <a:pPr lvl="0" indent="0" marL="0">
-              <a:buNone/>
-            </a:pPr>
-            <a:r>
-              <a:rPr i="1"/>
-              <a:t>(Drop in your actual Volto screenshot above this box)</a:t>
-            </a:r>
-          </a:p>
-        </p:txBody>
-      </p:sp>
+              <a:t>Quality Score:</a:t>
+            </a:r>
+            <a:r>
+              <a:t xml:space="preserve"> </a:t>
+            </a:r>
+            <a:r>
+              <a:rPr sz="1300"/>
+              <a:t xml:space="preserve"> Calibrated score from supported claims</a:t>
+            </a:r>
+          </a:p>
+        </p:txBody>
+      </p:sp>
+      <p:pic>
+        <p:nvPicPr>
+          <p:cNvPr descr="images/screenshot_placeholder.png" id="0" name="Picture 1"/>
+          <p:cNvPicPr>
+            <a:picLocks noGrp="1" noChangeAspect="1"/>
+          </p:cNvPicPr>
+          <p:nvPr/>
+        </p:nvPicPr>
+        <p:blipFill>
+          <a:blip r:embed="rId3"/>
+          <a:stretch>
+            <a:fillRect/>
+          </a:stretch>
+        </p:blipFill>
+        <p:spPr bwMode="auto">
+          <a:xfrm>
+            <a:off x="4648200" y="1651000"/>
+            <a:ext cx="4038600" cy="2463800"/>
+          </a:xfrm>
+          <a:prstGeom prst="rect">
+            <a:avLst/>
+          </a:prstGeom>
+          <a:noFill/>
+          <a:ln w="9525">
+            <a:noFill/>
+            <a:headEnd/>
+            <a:tailEnd/>
+          </a:ln>
+        </p:spPr>
+      </p:pic>
     </p:spTree>
   </p:cSld>
 </p:sld>

</xml_diff>